<commit_message>
Beta 1.44 Semi-working SDS
</commit_message>
<xml_diff>
--- a/backend/storage/app/Templates/Tags template.pptx
+++ b/backend/storage/app/Templates/Tags template.pptx
@@ -197,7 +197,7 @@
           <a:p>
             <a:fld id="{404309B4-38A1-4E09-8C30-663C85214DDB}" type="datetimeFigureOut">
               <a:rPr lang="fr-MA" smtClean="0"/>
-              <a:t>14/03/2026</a:t>
+              <a:t>15/03/2026</a:t>
             </a:fld>
             <a:endParaRPr lang="fr-MA"/>
           </a:p>
@@ -596,7 +596,7 @@
           <a:p>
             <a:fld id="{DB06CA5D-EE84-4C01-B57D-41C38433FB48}" type="datetimeFigureOut">
               <a:rPr lang="fr-MA" smtClean="0"/>
-              <a:t>14/03/2026</a:t>
+              <a:t>15/03/2026</a:t>
             </a:fld>
             <a:endParaRPr lang="fr-MA"/>
           </a:p>
@@ -766,7 +766,7 @@
           <a:p>
             <a:fld id="{DB06CA5D-EE84-4C01-B57D-41C38433FB48}" type="datetimeFigureOut">
               <a:rPr lang="fr-MA" smtClean="0"/>
-              <a:t>14/03/2026</a:t>
+              <a:t>15/03/2026</a:t>
             </a:fld>
             <a:endParaRPr lang="fr-MA"/>
           </a:p>
@@ -946,7 +946,7 @@
           <a:p>
             <a:fld id="{DB06CA5D-EE84-4C01-B57D-41C38433FB48}" type="datetimeFigureOut">
               <a:rPr lang="fr-MA" smtClean="0"/>
-              <a:t>14/03/2026</a:t>
+              <a:t>15/03/2026</a:t>
             </a:fld>
             <a:endParaRPr lang="fr-MA"/>
           </a:p>
@@ -1116,7 +1116,7 @@
           <a:p>
             <a:fld id="{DB06CA5D-EE84-4C01-B57D-41C38433FB48}" type="datetimeFigureOut">
               <a:rPr lang="fr-MA" smtClean="0"/>
-              <a:t>14/03/2026</a:t>
+              <a:t>15/03/2026</a:t>
             </a:fld>
             <a:endParaRPr lang="fr-MA"/>
           </a:p>
@@ -1362,7 +1362,7 @@
           <a:p>
             <a:fld id="{DB06CA5D-EE84-4C01-B57D-41C38433FB48}" type="datetimeFigureOut">
               <a:rPr lang="fr-MA" smtClean="0"/>
-              <a:t>14/03/2026</a:t>
+              <a:t>15/03/2026</a:t>
             </a:fld>
             <a:endParaRPr lang="fr-MA"/>
           </a:p>
@@ -1594,7 +1594,7 @@
           <a:p>
             <a:fld id="{DB06CA5D-EE84-4C01-B57D-41C38433FB48}" type="datetimeFigureOut">
               <a:rPr lang="fr-MA" smtClean="0"/>
-              <a:t>14/03/2026</a:t>
+              <a:t>15/03/2026</a:t>
             </a:fld>
             <a:endParaRPr lang="fr-MA"/>
           </a:p>
@@ -1961,7 +1961,7 @@
           <a:p>
             <a:fld id="{DB06CA5D-EE84-4C01-B57D-41C38433FB48}" type="datetimeFigureOut">
               <a:rPr lang="fr-MA" smtClean="0"/>
-              <a:t>14/03/2026</a:t>
+              <a:t>15/03/2026</a:t>
             </a:fld>
             <a:endParaRPr lang="fr-MA"/>
           </a:p>
@@ -2079,7 +2079,7 @@
           <a:p>
             <a:fld id="{DB06CA5D-EE84-4C01-B57D-41C38433FB48}" type="datetimeFigureOut">
               <a:rPr lang="fr-MA" smtClean="0"/>
-              <a:t>14/03/2026</a:t>
+              <a:t>15/03/2026</a:t>
             </a:fld>
             <a:endParaRPr lang="fr-MA"/>
           </a:p>
@@ -2174,7 +2174,7 @@
           <a:p>
             <a:fld id="{DB06CA5D-EE84-4C01-B57D-41C38433FB48}" type="datetimeFigureOut">
               <a:rPr lang="fr-MA" smtClean="0"/>
-              <a:t>14/03/2026</a:t>
+              <a:t>15/03/2026</a:t>
             </a:fld>
             <a:endParaRPr lang="fr-MA"/>
           </a:p>
@@ -2451,7 +2451,7 @@
           <a:p>
             <a:fld id="{DB06CA5D-EE84-4C01-B57D-41C38433FB48}" type="datetimeFigureOut">
               <a:rPr lang="fr-MA" smtClean="0"/>
-              <a:t>14/03/2026</a:t>
+              <a:t>15/03/2026</a:t>
             </a:fld>
             <a:endParaRPr lang="fr-MA"/>
           </a:p>
@@ -2708,7 +2708,7 @@
           <a:p>
             <a:fld id="{DB06CA5D-EE84-4C01-B57D-41C38433FB48}" type="datetimeFigureOut">
               <a:rPr lang="fr-MA" smtClean="0"/>
-              <a:t>14/03/2026</a:t>
+              <a:t>15/03/2026</a:t>
             </a:fld>
             <a:endParaRPr lang="fr-MA"/>
           </a:p>
@@ -2921,7 +2921,7 @@
           <a:p>
             <a:fld id="{DB06CA5D-EE84-4C01-B57D-41C38433FB48}" type="datetimeFigureOut">
               <a:rPr lang="fr-MA" smtClean="0"/>
-              <a:t>14/03/2026</a:t>
+              <a:t>15/03/2026</a:t>
             </a:fld>
             <a:endParaRPr lang="fr-MA"/>
           </a:p>
@@ -3668,7 +3668,7 @@
       </p:pic>
       <p:sp>
         <p:nvSpPr>
-          <p:cNvPr id="82" name="Product name">
+          <p:cNvPr id="82" name="kcndksn">
             <a:extLst>
               <a:ext uri="{FF2B5EF4-FFF2-40B4-BE49-F238E27FC236}">
                 <a16:creationId xmlns:a16="http://schemas.microsoft.com/office/drawing/2014/main" id="{B7422D20-B02B-7975-CD06-10B8FF14BD9A}"/>
@@ -4118,7 +4118,7 @@
       </p:pic>
       <p:sp>
         <p:nvSpPr>
-          <p:cNvPr id="102" name="Product name">
+          <p:cNvPr id="102" name="kcjndksc">
             <a:extLst>
               <a:ext uri="{FF2B5EF4-FFF2-40B4-BE49-F238E27FC236}">
                 <a16:creationId xmlns:a16="http://schemas.microsoft.com/office/drawing/2014/main" id="{923C7577-B421-359B-8542-BE5A06B1E080}"/>
@@ -4568,7 +4568,7 @@
       </p:pic>
       <p:sp>
         <p:nvSpPr>
-          <p:cNvPr id="112" name="Product name">
+          <p:cNvPr id="112" name="kcjndksjcn">
             <a:extLst>
               <a:ext uri="{FF2B5EF4-FFF2-40B4-BE49-F238E27FC236}">
                 <a16:creationId xmlns:a16="http://schemas.microsoft.com/office/drawing/2014/main" id="{62522A7F-528E-0EE2-B65B-3359D2B5A937}"/>
@@ -5018,7 +5018,7 @@
       </p:pic>
       <p:sp>
         <p:nvSpPr>
-          <p:cNvPr id="122" name="Product name">
+          <p:cNvPr id="122" name="cjndskjcns">
             <a:extLst>
               <a:ext uri="{FF2B5EF4-FFF2-40B4-BE49-F238E27FC236}">
                 <a16:creationId xmlns:a16="http://schemas.microsoft.com/office/drawing/2014/main" id="{A28D9ECA-DEB6-A61E-BB15-D168DC75AAD4}"/>
@@ -6289,7 +6289,7 @@
       </p:pic>
       <p:sp>
         <p:nvSpPr>
-          <p:cNvPr id="132" name="Product name">
+          <p:cNvPr id="132" name="jnckjs">
             <a:extLst>
               <a:ext uri="{FF2B5EF4-FFF2-40B4-BE49-F238E27FC236}">
                 <a16:creationId xmlns:a16="http://schemas.microsoft.com/office/drawing/2014/main" id="{FE23C22D-F0C8-D1DF-1A37-942C3262FC56}"/>

</xml_diff>